<commit_message>
Add live product URL to README and defense deck
</commit_message>
<xml_diff>
--- a/presentation/Tashkent_Apartment_Price_Defense.pptx
+++ b/presentation/Tashkent_Apartment_Price_Defense.pptx
@@ -10194,7 +10194,7 @@
                 </a:solidFill>
                 <a:latin typeface="Aptos"/>
               </a:rPr>
-              <a:t>Colab route: setup → load saved pipeline → predict → show validation error.</a:t>
+              <a:t>Website route: enter a real apartment → estimate → comparable market evidence.</a:t>
             </a:r>
           </a:p>
         </p:txBody>
@@ -10428,7 +10428,7 @@
                 </a:solidFill>
                 <a:latin typeface="Aptos"/>
               </a:rPr>
-              <a:t>ESTIMATED AUGUST 2026 ASKING PRICE</a:t>
+              <a:t>ESTIMATED ADVERTISED ASKING PRICE</a:t>
             </a:r>
           </a:p>
         </p:txBody>
@@ -10585,7 +10585,9 @@
       </p:sp>
       <p:sp>
         <p:nvSpPr>
-          <p:cNvPr id="21" name="TextBox 20"/>
+          <p:cNvPr id="21" name="TextBox 20">
+            <a:hlinkClick r:id="rId2"/>
+          </p:cNvPr>
           <p:cNvSpPr txBox="1"/>
           <p:nvPr/>
         </p:nvSpPr>
@@ -10613,7 +10615,7 @@
                 </a:solidFill>
                 <a:latin typeface="Aptos"/>
               </a:rPr>
-              <a:t>Open: README Colab badge  •  Run all  •  Do not tour source code unless asked</a:t>
+              <a:t>LIVE DEMO: tashkent-apartment-price-predictor.streamlit.app</a:t>
             </a:r>
           </a:p>
         </p:txBody>

</xml_diff>